<commit_message>
Playbook: agrega logo del Parque Memorial Las Colinas
Co-Authored-By: Claude Opus 5.5 <noreply@anthropic.com>
Claude-Session: https://claude.ai/code/session_0111i7vn9WWo4QxCQbucWbrF
</commit_message>
<xml_diff>
--- a/playbook/salida/Playbook_Comercial_Cremacion_Vangrupo_Vertical.pptx
+++ b/playbook/salida/Playbook_Comercial_Cremacion_Vangrupo_Vertical.pptx
@@ -3179,8 +3179,8 @@
         </p:blipFill>
         <p:spPr>
           <a:xfrm>
-            <a:off x="640080" y="805742"/>
-            <a:ext cx="2002536" cy="628796"/>
+            <a:off x="640080" y="889725"/>
+            <a:ext cx="1467612" cy="460830"/>
           </a:xfrm>
           <a:prstGeom prst="rect">
             <a:avLst/>
@@ -3203,8 +3203,8 @@
         </p:blipFill>
         <p:spPr>
           <a:xfrm>
-            <a:off x="2779776" y="719633"/>
-            <a:ext cx="2002536" cy="801014"/>
+            <a:off x="2244852" y="826618"/>
+            <a:ext cx="1467612" cy="587044"/>
           </a:xfrm>
           <a:prstGeom prst="rect">
             <a:avLst/>
@@ -3213,7 +3213,7 @@
       </p:pic>
       <p:pic>
         <p:nvPicPr>
-          <p:cNvPr id="5" name="Picture 4" descr="vangrupo.png"/>
+          <p:cNvPr id="5" name="Picture 4" descr="las_colinas.png"/>
           <p:cNvPicPr>
             <a:picLocks noChangeAspect="1"/>
           </p:cNvPicPr>
@@ -3227,17 +3227,41 @@
         </p:blipFill>
         <p:spPr>
           <a:xfrm>
-            <a:off x="4919472" y="863559"/>
-            <a:ext cx="2002536" cy="513162"/>
+            <a:off x="3890223" y="685800"/>
+            <a:ext cx="1386413" cy="868680"/>
           </a:xfrm>
           <a:prstGeom prst="rect">
             <a:avLst/>
           </a:prstGeom>
         </p:spPr>
       </p:pic>
-      <p:sp>
-        <p:nvSpPr>
-          <p:cNvPr id="6" name="TextBox 5"/>
+      <p:pic>
+        <p:nvPicPr>
+          <p:cNvPr id="6" name="Picture 5" descr="vangrupo.png"/>
+          <p:cNvPicPr>
+            <a:picLocks noChangeAspect="1"/>
+          </p:cNvPicPr>
+          <p:nvPr/>
+        </p:nvPicPr>
+        <p:blipFill>
+          <a:blip r:embed="rId5"/>
+          <a:stretch>
+            <a:fillRect/>
+          </a:stretch>
+        </p:blipFill>
+        <p:spPr>
+          <a:xfrm>
+            <a:off x="5454396" y="932098"/>
+            <a:ext cx="1467612" cy="376084"/>
+          </a:xfrm>
+          <a:prstGeom prst="rect">
+            <a:avLst/>
+          </a:prstGeom>
+        </p:spPr>
+      </p:pic>
+      <p:sp>
+        <p:nvSpPr>
+          <p:cNvPr id="7" name="TextBox 6"/>
           <p:cNvSpPr txBox="1"/>
           <p:nvPr/>
         </p:nvSpPr>
@@ -3279,7 +3303,7 @@
       </p:sp>
       <p:sp>
         <p:nvSpPr>
-          <p:cNvPr id="7" name="TextBox 6"/>
+          <p:cNvPr id="8" name="TextBox 7"/>
           <p:cNvSpPr txBox="1"/>
           <p:nvPr/>
         </p:nvSpPr>
@@ -3340,7 +3364,7 @@
       </p:sp>
       <p:sp>
         <p:nvSpPr>
-          <p:cNvPr id="8" name="TextBox 7"/>
+          <p:cNvPr id="9" name="TextBox 8"/>
           <p:cNvSpPr txBox="1"/>
           <p:nvPr/>
         </p:nvSpPr>
@@ -3382,7 +3406,7 @@
       </p:sp>
       <p:sp>
         <p:nvSpPr>
-          <p:cNvPr id="9" name="Rectangle 8"/>
+          <p:cNvPr id="10" name="Rectangle 9"/>
           <p:cNvSpPr/>
           <p:nvPr/>
         </p:nvSpPr>
@@ -3426,7 +3450,7 @@
       </p:sp>
       <p:sp>
         <p:nvSpPr>
-          <p:cNvPr id="10" name="TextBox 9"/>
+          <p:cNvPr id="11" name="TextBox 10"/>
           <p:cNvSpPr txBox="1"/>
           <p:nvPr/>
         </p:nvSpPr>
@@ -3468,7 +3492,7 @@
       </p:sp>
       <p:sp>
         <p:nvSpPr>
-          <p:cNvPr id="11" name="TextBox 10"/>
+          <p:cNvPr id="12" name="TextBox 11"/>
           <p:cNvSpPr txBox="1"/>
           <p:nvPr/>
         </p:nvSpPr>
@@ -3510,7 +3534,7 @@
       </p:sp>
       <p:sp>
         <p:nvSpPr>
-          <p:cNvPr id="12" name="TextBox 11"/>
+          <p:cNvPr id="13" name="TextBox 12"/>
           <p:cNvSpPr txBox="1"/>
           <p:nvPr/>
         </p:nvSpPr>
@@ -3552,7 +3576,7 @@
       </p:sp>
       <p:sp>
         <p:nvSpPr>
-          <p:cNvPr id="13" name="Rectangle 12"/>
+          <p:cNvPr id="14" name="Rectangle 13"/>
           <p:cNvSpPr/>
           <p:nvPr/>
         </p:nvSpPr>
@@ -20978,8 +21002,8 @@
         </p:blipFill>
         <p:spPr>
           <a:xfrm>
-            <a:off x="640080" y="8669582"/>
-            <a:ext cx="2002536" cy="628796"/>
+            <a:off x="640080" y="8753565"/>
+            <a:ext cx="1467612" cy="460830"/>
           </a:xfrm>
           <a:prstGeom prst="rect">
             <a:avLst/>
@@ -21002,8 +21026,8 @@
         </p:blipFill>
         <p:spPr>
           <a:xfrm>
-            <a:off x="2779776" y="8583473"/>
-            <a:ext cx="2002536" cy="801014"/>
+            <a:off x="2244852" y="8690458"/>
+            <a:ext cx="1467612" cy="587044"/>
           </a:xfrm>
           <a:prstGeom prst="rect">
             <a:avLst/>
@@ -21012,7 +21036,7 @@
       </p:pic>
       <p:pic>
         <p:nvPicPr>
-          <p:cNvPr id="8" name="Picture 7" descr="vangrupo.png"/>
+          <p:cNvPr id="8" name="Picture 7" descr="las_colinas.png"/>
           <p:cNvPicPr>
             <a:picLocks noChangeAspect="1"/>
           </p:cNvPicPr>
@@ -21026,17 +21050,41 @@
         </p:blipFill>
         <p:spPr>
           <a:xfrm>
-            <a:off x="4919472" y="8727399"/>
-            <a:ext cx="2002536" cy="513162"/>
+            <a:off x="3890223" y="8549640"/>
+            <a:ext cx="1386413" cy="868680"/>
           </a:xfrm>
           <a:prstGeom prst="rect">
             <a:avLst/>
           </a:prstGeom>
         </p:spPr>
       </p:pic>
-      <p:sp>
-        <p:nvSpPr>
-          <p:cNvPr id="9" name="Rectangle 8"/>
+      <p:pic>
+        <p:nvPicPr>
+          <p:cNvPr id="9" name="Picture 8" descr="vangrupo.png"/>
+          <p:cNvPicPr>
+            <a:picLocks noChangeAspect="1"/>
+          </p:cNvPicPr>
+          <p:nvPr/>
+        </p:nvPicPr>
+        <p:blipFill>
+          <a:blip r:embed="rId5"/>
+          <a:stretch>
+            <a:fillRect/>
+          </a:stretch>
+        </p:blipFill>
+        <p:spPr>
+          <a:xfrm>
+            <a:off x="5454396" y="8795938"/>
+            <a:ext cx="1467612" cy="376084"/>
+          </a:xfrm>
+          <a:prstGeom prst="rect">
+            <a:avLst/>
+          </a:prstGeom>
+        </p:spPr>
+      </p:pic>
+      <p:sp>
+        <p:nvSpPr>
+          <p:cNvPr id="10" name="Rectangle 9"/>
           <p:cNvSpPr/>
           <p:nvPr/>
         </p:nvSpPr>

</xml_diff>